<commit_message>
pitch: recapture deck plates under Wayside, drop the rename caveat
The deck's room.png and phone.png were captured before the rename, so
slides 7 and 8 carried an apology for showing the old working name —
including a whole "ON RECORD" card given over to explaining it. The
rename is finished in the product (no user-facing occurrences of the old
name remain in the shipped UI), so the caveat was describing work that
is done.

Recaptured both plates from the live demo at the exact aspect ratios
build_deck.js places them at (2200x1231 and ~1.006), and reclaimed the
ON RECORD card for a real proof point: the signed provenance trail,
which is what the coordinator plate beside it actually shows.

Also corrects the automated-test count, which the deck understated as
111 in three places and the README as 184; the suite is 211.

Co-Authored-By: Claude Opus 5 <noreply@anthropic.com>
Claude-Session: https://claude.ai/code/session_01SXAoy28DpfihJRMx97Lrf4
</commit_message>
<xml_diff>
--- a/research/pitch/wayside-kxic-pitch.pptx
+++ b/research/pitch/wayside-kxic-pitch.pptx
@@ -2368,7 +2368,7 @@
                 <a:ea typeface="Arial" pitchFamily="34" charset="-122"/>
                 <a:cs typeface="Arial" pitchFamily="34" charset="-120"/>
               </a:rPr>
-              <a:t>Working demo · 111 tests</a:t>
+              <a:t>Working demo · 211 tests</a:t>
             </a:r>
             <a:endParaRPr lang="en-US" sz="1200" dirty="0"/>
           </a:p>
@@ -7437,7 +7437,7 @@
                 <a:ea typeface="Arial" pitchFamily="34" charset="-122"/>
                 <a:cs typeface="Arial" pitchFamily="34" charset="-120"/>
               </a:rPr>
-              <a:t>Equitech alum. Built the whole system solo — intake pipeline, control room, responder app, 111 automated tests — before asking anyone for a rupee. Every design choice in it cites a real system that came before and failed, for a specific, documented reason.</a:t>
+              <a:t>Equitech alum. Built the whole system solo — intake pipeline, control room, responder app, 211 automated tests — before asking anyone for a rupee. Every design choice in it cites a real system that came before and failed, for a specific, documented reason.</a:t>
             </a:r>
             <a:endParaRPr lang="en-US" sz="1250" dirty="0"/>
           </a:p>
@@ -8179,7 +8179,7 @@
                 <a:ea typeface="Courier New" pitchFamily="34" charset="-122"/>
                 <a:cs typeface="Courier New" pitchFamily="34" charset="-120"/>
               </a:rPr>
-              <a:t>the witness's phone — no app to install (shown under the project's original working name; a rename pass to Wayside is under way)</a:t>
+              <a:t>the witness's phone — no app to install</a:t>
             </a:r>
             <a:endParaRPr lang="en-US" sz="900" dirty="0"/>
           </a:p>
@@ -9070,7 +9070,7 @@
                 <a:ea typeface="Arial" pitchFamily="34" charset="-122"/>
                 <a:cs typeface="Arial" pitchFamily="34" charset="-120"/>
               </a:rPr>
-              <a:t>111 automated tests. Three real surfaces — control room, responder phone, witness phone — running the same loop end to end, offline, with zero paid API calls.</a:t>
+              <a:t>211 automated tests. Three real surfaces — control room, responder phone, witness phone — running the same loop end to end, offline, with zero paid API calls.</a:t>
             </a:r>
             <a:endParaRPr lang="en-US" sz="1400" dirty="0"/>
           </a:p>
@@ -9783,7 +9783,7 @@
         <p:spPr>
           <a:xfrm>
             <a:off x="7178040" y="2788920"/>
-            <a:ext cx="4206240" cy="1463040"/>
+            <a:ext cx="4206240" cy="1737360"/>
           </a:xfrm>
           <a:prstGeom prst="rect">
             <a:avLst/>
@@ -9810,7 +9810,7 @@
                 <a:ea typeface="Arial" pitchFamily="34" charset="-122"/>
                 <a:cs typeface="Arial" pitchFamily="34" charset="-120"/>
               </a:rPr>
-              <a:t>Screens shown as captured during development, under the project's original working name — a rename pass to Wayside is under way across the running product.</a:t>
+              <a:t>Every case carries a signed trail — who reported it, what the agent inferred, which responder closed it. Witness reports and agent inferences are HMAC-tagged; a responder's observations are labelled as observations, never as fact.</a:t>
             </a:r>
             <a:endParaRPr lang="en-US" sz="1200" dirty="0"/>
           </a:p>

</xml_diff>

<commit_message>
overnight r12: the founder's morning summary; deck says 224
A read-this-first overnight summary now tops research/loop-log.md —
pull target (35139f34c+), the twelve rounds condensed by theme, the two
artifact links, and the checklist pointer. The deck's title chip and
pitch text still claimed 217 tests; corrected to 224 and rebuilt.

Co-Authored-By: Claude Opus 5 <noreply@anthropic.com>
Claude-Session: https://claude.ai/code/session_01SXAoy28DpfihJRMx97Lrf4
</commit_message>
<xml_diff>
--- a/research/pitch/wayside-kxic-pitch.pptx
+++ b/research/pitch/wayside-kxic-pitch.pptx
@@ -2368,7 +2368,7 @@
                 <a:ea typeface="Arial" pitchFamily="34" charset="-122"/>
                 <a:cs typeface="Arial" pitchFamily="34" charset="-120"/>
               </a:rPr>
-              <a:t>Working demo · 217 tests</a:t>
+              <a:t>Working demo · 224 tests</a:t>
             </a:r>
             <a:endParaRPr lang="en-US" sz="1200" dirty="0"/>
           </a:p>
@@ -7437,7 +7437,7 @@
                 <a:ea typeface="Arial" pitchFamily="34" charset="-122"/>
                 <a:cs typeface="Arial" pitchFamily="34" charset="-120"/>
               </a:rPr>
-              <a:t>Equitech alum. Built the whole system solo — intake pipeline, control room, responder app, 217 automated tests — before asking anyone for a rupee. Every design choice in it cites a real system that came before and failed, for a specific, documented reason.</a:t>
+              <a:t>Equitech alum. Built the whole system solo — intake pipeline, control room, responder app, 224 automated tests — before asking anyone for a rupee. Every design choice in it cites a real system that came before and failed, for a specific, documented reason.</a:t>
             </a:r>
             <a:endParaRPr lang="en-US" sz="1250" dirty="0"/>
           </a:p>
@@ -9070,7 +9070,7 @@
                 <a:ea typeface="Arial" pitchFamily="34" charset="-122"/>
                 <a:cs typeface="Arial" pitchFamily="34" charset="-120"/>
               </a:rPr>
-              <a:t>217 automated tests. Three real surfaces — control room, responder phone, witness phone — running the same loop end to end, offline, with zero paid API calls.</a:t>
+              <a:t>224 automated tests. Three real surfaces — control room, responder phone, witness phone — running the same loop end to end, offline, with zero paid API calls.</a:t>
             </a:r>
             <a:endParaRPr lang="en-US" sz="1400" dirty="0"/>
           </a:p>

</xml_diff>

<commit_message>
pitch: the deck's screenshots show the real map, and it says 245
The deck's hero screenshot was the single loudest thing still claiming
the invented city: room.png showed the generated street grid with
"demo geometry — representative, not surveyed" printed in the corner,
and phone.png did the same on the witness surface. Both recaptured at
their exact deck dimensions against the real import — Sunder Nursery,
Humayun's Tomb, Isa Khan's Tomb, Sabz Burj, Mathura Road, the railway,
and "© OpenStreetMap contributors" where the old disclaimer used to be.

The other four assets carry no map (coordinator queue, case detail, the
responder's kit checklist and offer card, metrics) and are unchanged.

Test count corrected 224 -> 245 in build_deck.js and the plain-text
pitch, and the pptx rebuilt from both.

Co-Authored-By: Claude Opus 5 <noreply@anthropic.com>
Claude-Session: https://claude.ai/code/session_017MKvYAT9nyCNmnnjehJD2o
</commit_message>
<xml_diff>
--- a/research/pitch/wayside-kxic-pitch.pptx
+++ b/research/pitch/wayside-kxic-pitch.pptx
@@ -2368,7 +2368,7 @@
                 <a:ea typeface="Arial" pitchFamily="34" charset="-122"/>
                 <a:cs typeface="Arial" pitchFamily="34" charset="-120"/>
               </a:rPr>
-              <a:t>Working demo · 224 tests</a:t>
+              <a:t>Working demo · 245 tests</a:t>
             </a:r>
             <a:endParaRPr lang="en-US" sz="1200" dirty="0"/>
           </a:p>
@@ -7437,7 +7437,7 @@
                 <a:ea typeface="Arial" pitchFamily="34" charset="-122"/>
                 <a:cs typeface="Arial" pitchFamily="34" charset="-120"/>
               </a:rPr>
-              <a:t>Equitech alum. Built the whole system solo — intake pipeline, control room, responder app, 224 automated tests — before asking anyone for a rupee. Every design choice in it cites a real system that came before and failed, for a specific, documented reason.</a:t>
+              <a:t>Equitech alum. Built the whole system solo — intake pipeline, control room, responder app, 245 automated tests — before asking anyone for a rupee. Every design choice in it cites a real system that came before and failed, for a specific, documented reason.</a:t>
             </a:r>
             <a:endParaRPr lang="en-US" sz="1250" dirty="0"/>
           </a:p>
@@ -9070,7 +9070,7 @@
                 <a:ea typeface="Arial" pitchFamily="34" charset="-122"/>
                 <a:cs typeface="Arial" pitchFamily="34" charset="-120"/>
               </a:rPr>
-              <a:t>224 automated tests. Three real surfaces — control room, responder phone, witness phone — running the same loop end to end, offline, with zero paid API calls.</a:t>
+              <a:t>245 automated tests. Three real surfaces — control room, responder phone, witness phone — running the same loop end to end, offline, with zero paid API calls.</a:t>
             </a:r>
             <a:endParaRPr lang="en-US" sz="1400" dirty="0"/>
           </a:p>

</xml_diff>